<commit_message>
Rewrite insight PPT copy without ellipsis truncation
Keep complete sentences and clear viewpoints for PAI and Agent Infra
one-pagers; expand layout so insight/judgment wrap fully.

Co-authored-by: Annie <Annie-Summer@users.noreply.github.com>
</commit_message>
<xml_diff>
--- a/yunqi-2026-agenda-201/docs/洞察一页-01-企业级大规模 Agent Infra 解决方案最佳实践.pptx
+++ b/yunqi-2026-agenda-201/docs/洞察一页-01-企业级大规模 Agent Infra 解决方案最佳实践.pptx
@@ -3141,7 +3141,7 @@
         <p:spPr>
           <a:xfrm>
             <a:off x="0" y="0"/>
-            <a:ext cx="12191695" cy="1051560"/>
+            <a:ext cx="12191695" cy="1097280"/>
           </a:xfrm>
           <a:prstGeom prst="rect">
             <a:avLst/>
@@ -3183,8 +3183,8 @@
         </p:nvSpPr>
         <p:spPr>
           <a:xfrm>
-            <a:off x="365760" y="146304"/>
-            <a:ext cx="11430000" cy="274320"/>
+            <a:off x="320040" y="91440"/>
+            <a:ext cx="11521440" cy="237744"/>
           </a:xfrm>
           <a:prstGeom prst="rect">
             <a:avLst/>
@@ -3199,7 +3199,7 @@
           <a:p>
             <a:pPr algn="l"/>
             <a:r>
-              <a:rPr sz="1300" b="0">
+              <a:rPr sz="1200" b="0">
                 <a:solidFill>
                   <a:srgbClr val="6B6B6B"/>
                 </a:solidFill>
@@ -3219,8 +3219,8 @@
         </p:nvSpPr>
         <p:spPr>
           <a:xfrm>
-            <a:off x="365760" y="420624"/>
-            <a:ext cx="11430000" cy="502920"/>
+            <a:off x="320040" y="347472"/>
+            <a:ext cx="11521440" cy="658368"/>
           </a:xfrm>
           <a:prstGeom prst="rect">
             <a:avLst/>
@@ -3235,14 +3235,14 @@
           <a:p>
             <a:pPr algn="l"/>
             <a:r>
-              <a:rPr sz="2000" b="1">
+              <a:rPr sz="1600" b="1">
                 <a:solidFill>
                   <a:srgbClr val="1A1A1A"/>
                 </a:solidFill>
                 <a:latin typeface="Microsoft YaHei"/>
                 <a:ea typeface="Microsoft YaHei"/>
               </a:rPr>
-              <a:t>洞察：HCS 应立项「Agent 平台」整包能力：MicroVM 沙箱（Serverless API…</a:t>
+              <a:t>洞察：HCS 应立项「Agent 平台」整包能力：MicroVM 沙箱（Serverless API + K8s CRD）、Skills/MCP 私有市场、上下文/记忆存储、AI 网关护栏与 AgentLoop 级可观测，对标阿里云 Agent Infra 五支柱。</a:t>
             </a:r>
           </a:p>
         </p:txBody>
@@ -3255,8 +3255,8 @@
         </p:nvSpPr>
         <p:spPr>
           <a:xfrm>
-            <a:off x="320040" y="1207008"/>
-            <a:ext cx="11521440" cy="502920"/>
+            <a:off x="274320" y="1207008"/>
+            <a:ext cx="11612880" cy="749808"/>
           </a:xfrm>
           <a:prstGeom prst="rect">
             <a:avLst/>
@@ -3300,8 +3300,8 @@
         </p:nvSpPr>
         <p:spPr>
           <a:xfrm>
-            <a:off x="457200" y="1298448"/>
-            <a:ext cx="11247120" cy="365760"/>
+            <a:off x="411480" y="1261872"/>
+            <a:ext cx="11338560" cy="640080"/>
           </a:xfrm>
           <a:prstGeom prst="rect">
             <a:avLst/>
@@ -3316,14 +3316,14 @@
           <a:p>
             <a:pPr algn="l"/>
             <a:r>
-              <a:rPr sz="1300" b="1">
+              <a:rPr sz="1200" b="1">
                 <a:solidFill>
                   <a:srgbClr val="1A1A1A"/>
                 </a:solidFill>
                 <a:latin typeface="Microsoft YaHei"/>
                 <a:ea typeface="Microsoft YaHei"/>
               </a:rPr>
-              <a:t>一句话判断：本场系统给出阿里云企业级 Agent Infra 的形态判断与产品架构：桌面助手/云端数字分身与 Agent Serving 两条主线并行，统一沉淀企业专属 Skills、MCP 与私域知识。Infra 不再追求模型永…</a:t>
+              <a:t>一句话判断：本场系统给出阿里云企业级 Agent Infra 的形态判断与产品架构：桌面助手/云端数字分身与 Agent Serving 两条主线并行，统一沉淀企业专属 Skills、MCP 与私域知识。</a:t>
             </a:r>
           </a:p>
         </p:txBody>
@@ -3336,8 +3336,8 @@
         </p:nvSpPr>
         <p:spPr>
           <a:xfrm>
-            <a:off x="320040" y="1874519"/>
-            <a:ext cx="3703320" cy="2606040"/>
+            <a:off x="274320" y="2084831"/>
+            <a:ext cx="3749039" cy="2267712"/>
           </a:xfrm>
           <a:prstGeom prst="rect">
             <a:avLst/>
@@ -3381,8 +3381,8 @@
         </p:nvSpPr>
         <p:spPr>
           <a:xfrm>
-            <a:off x="457200" y="2011679"/>
-            <a:ext cx="3429000" cy="320040"/>
+            <a:off x="402336" y="2176271"/>
+            <a:ext cx="3493007" cy="292608"/>
           </a:xfrm>
           <a:prstGeom prst="rect">
             <a:avLst/>
@@ -3397,14 +3397,14 @@
           <a:p>
             <a:pPr algn="l"/>
             <a:r>
-              <a:rPr sz="1500" b="1">
+              <a:rPr sz="1400" b="1">
                 <a:solidFill>
                   <a:srgbClr val="8B1A2B"/>
                 </a:solidFill>
                 <a:latin typeface="Microsoft YaHei"/>
                 <a:ea typeface="Microsoft YaHei"/>
               </a:rPr>
-              <a:t>01  Agent 形态演进：桌面分身…</a:t>
+              <a:t>01  桌面分身与 Serving 双路径</a:t>
             </a:r>
           </a:p>
         </p:txBody>
@@ -3417,8 +3417,8 @@
         </p:nvSpPr>
         <p:spPr>
           <a:xfrm>
-            <a:off x="484632" y="2377439"/>
-            <a:ext cx="3374136" cy="1965960"/>
+            <a:off x="402336" y="2487167"/>
+            <a:ext cx="3493007" cy="1764792"/>
           </a:xfrm>
           <a:prstGeom prst="rect">
             <a:avLst/>
@@ -3433,52 +3433,69 @@
           <a:p>
             <a:pPr algn="l">
               <a:spcAft>
-                <a:spcPts val="400"/>
+                <a:spcPts val="200"/>
               </a:spcAft>
             </a:pPr>
             <a:r>
-              <a:rPr sz="1200" b="1">
+              <a:rPr sz="1100" b="1">
                 <a:solidFill>
                   <a:srgbClr val="1A1A1A"/>
                 </a:solidFill>
                 <a:latin typeface="Microsoft YaHei"/>
                 <a:ea typeface="Microsoft YaHei"/>
               </a:rPr>
-              <a:t>桌面助手/云端数字分身面向内部提效：IM/本地客户端 + 云端 Sandbox 协…</a:t>
+              <a:t>HCS 规划应同时覆盖「办公助手类长会话 Agent」与「生产系统 Serving Agent」两套产品形态</a:t>
             </a:r>
           </a:p>
           <a:p>
             <a:pPr algn="l">
               <a:spcAft>
-                <a:spcPts val="400"/>
+                <a:spcPts val="200"/>
               </a:spcAft>
             </a:pPr>
             <a:r>
-              <a:rPr sz="1200" b="0">
+              <a:rPr sz="1100" b="0">
                 <a:solidFill>
                   <a:srgbClr val="4A4A4A"/>
                 </a:solidFill>
                 <a:latin typeface="Microsoft YaHei"/>
                 <a:ea typeface="Microsoft YaHei"/>
               </a:rPr>
-              <a:t>• Agent Serving/API 对接生产系统：垂直超级 Agent 基于私域数据，强调隔离、用户授权、Skills 管理与 Mem…</a:t>
+              <a:t>• 桌面助手/云端数字分身面向内部提效：IM/本地客户端 + 云端 Sandbox 协同，支持 7×24 独立运行与共享记忆</a:t>
             </a:r>
           </a:p>
           <a:p>
             <a:pPr algn="l">
               <a:spcAft>
-                <a:spcPts val="400"/>
+                <a:spcPts val="200"/>
               </a:spcAft>
             </a:pPr>
             <a:r>
-              <a:rPr sz="1200" b="0">
+              <a:rPr sz="1100" b="0">
                 <a:solidFill>
                   <a:srgbClr val="4A4A4A"/>
                 </a:solidFill>
                 <a:latin typeface="Microsoft YaHei"/>
                 <a:ea typeface="Microsoft YaHei"/>
               </a:rPr>
-              <a:t>• ToB/ToC/ToD 入口趋于统一，企业重点积累专属 Skills、MCP 与知识；Harness 建议扩展成熟框架而非自研底层。</a:t>
+              <a:t>• Agent Serving/API 对接生产系统：垂直超级 Agent 基于私域数据，强调隔离、用户授权、Skills 管理与 Memory 隔离</a:t>
+            </a:r>
+          </a:p>
+          <a:p>
+            <a:pPr algn="l">
+              <a:spcAft>
+                <a:spcPts val="200"/>
+              </a:spcAft>
+            </a:pPr>
+            <a:r>
+              <a:rPr sz="1100" b="0">
+                <a:solidFill>
+                  <a:srgbClr val="4A4A4A"/>
+                </a:solidFill>
+                <a:latin typeface="Microsoft YaHei"/>
+                <a:ea typeface="Microsoft YaHei"/>
+              </a:rPr>
+              <a:t>• ToB/ToC/ToD 入口趋于统一，企业重点积累专属 Skills、MCP 与知识</a:t>
             </a:r>
           </a:p>
         </p:txBody>
@@ -3491,8 +3508,8 @@
         </p:nvSpPr>
         <p:spPr>
           <a:xfrm>
-            <a:off x="4224528" y="1874519"/>
-            <a:ext cx="3703320" cy="2606040"/>
+            <a:off x="4187951" y="2084831"/>
+            <a:ext cx="3749039" cy="2267712"/>
           </a:xfrm>
           <a:prstGeom prst="rect">
             <a:avLst/>
@@ -3536,8 +3553,8 @@
         </p:nvSpPr>
         <p:spPr>
           <a:xfrm>
-            <a:off x="4361688" y="2011679"/>
-            <a:ext cx="3429000" cy="320040"/>
+            <a:off x="4315967" y="2176271"/>
+            <a:ext cx="3493007" cy="292608"/>
           </a:xfrm>
           <a:prstGeom prst="rect">
             <a:avLst/>
@@ -3552,14 +3569,14 @@
           <a:p>
             <a:pPr algn="l"/>
             <a:r>
-              <a:rPr sz="1500" b="1">
+              <a:rPr sz="1400" b="1">
                 <a:solidFill>
                   <a:srgbClr val="8B1A2B"/>
                 </a:solidFill>
                 <a:latin typeface="Microsoft YaHei"/>
                 <a:ea typeface="Microsoft YaHei"/>
               </a:rPr>
-              <a:t>02  Agent 对 Infra 提…</a:t>
+              <a:t>02  Agent 对 Infra 提出的四大挑战</a:t>
             </a:r>
           </a:p>
         </p:txBody>
@@ -3572,8 +3589,8 @@
         </p:nvSpPr>
         <p:spPr>
           <a:xfrm>
-            <a:off x="4389120" y="2377439"/>
-            <a:ext cx="3374136" cy="1965960"/>
+            <a:off x="4315967" y="2487167"/>
+            <a:ext cx="3493007" cy="1764792"/>
           </a:xfrm>
           <a:prstGeom prst="rect">
             <a:avLst/>
@@ -3588,45 +3605,62 @@
           <a:p>
             <a:pPr algn="l">
               <a:spcAft>
-                <a:spcPts val="400"/>
+                <a:spcPts val="200"/>
               </a:spcAft>
             </a:pPr>
             <a:r>
-              <a:rPr sz="1200" b="1">
+              <a:rPr sz="1100" b="1">
                 <a:solidFill>
                   <a:srgbClr val="1A1A1A"/>
                 </a:solidFill>
                 <a:latin typeface="Microsoft YaHei"/>
                 <a:ea typeface="Microsoft YaHei"/>
               </a:rPr>
-              <a:t>高性能安全执行环境：Agent 需快速弹性、安全隔离地执行生成代码、操作系统交互与…</a:t>
+              <a:t>HCS 技术规划应把 Agent Infra 拆成执行沙箱、IAM/审计、上下文存储、可观测评测四条独立能力线，避免只堆推理网关</a:t>
             </a:r>
           </a:p>
           <a:p>
             <a:pPr algn="l">
               <a:spcAft>
-                <a:spcPts val="400"/>
+                <a:spcPts val="200"/>
               </a:spcAft>
             </a:pPr>
             <a:r>
-              <a:rPr sz="1200" b="0">
+              <a:rPr sz="1100" b="0">
                 <a:solidFill>
                   <a:srgbClr val="4A4A4A"/>
                 </a:solidFill>
                 <a:latin typeface="Microsoft YaHei"/>
                 <a:ea typeface="Microsoft YaHei"/>
               </a:rPr>
-              <a:t>• Agent 治理与数据安全：统一管理 Agent/模型/工具（Skills、MCP），身份认证、细粒度权限与使用审计。</a:t>
+              <a:t>• 高性能安全执行环境：Agent 需快速弹性、安全隔离地执行生成代码、操作系统交互与工具调用，自建成本高、隔离难。</a:t>
             </a:r>
           </a:p>
           <a:p>
             <a:pPr algn="l">
               <a:spcAft>
-                <a:spcPts val="400"/>
+                <a:spcPts val="200"/>
               </a:spcAft>
             </a:pPr>
             <a:r>
-              <a:rPr sz="1200" b="0">
+              <a:rPr sz="1100" b="0">
+                <a:solidFill>
+                  <a:srgbClr val="4A4A4A"/>
+                </a:solidFill>
+                <a:latin typeface="Microsoft YaHei"/>
+                <a:ea typeface="Microsoft YaHei"/>
+              </a:rPr>
+              <a:t>• Agent 治理与数据安全：统一管理 Agent/模型/工具（Skills、MCP），身份认证、细粒度权限与使用审计</a:t>
+            </a:r>
+          </a:p>
+          <a:p>
+            <a:pPr algn="l">
+              <a:spcAft>
+                <a:spcPts val="200"/>
+              </a:spcAft>
+            </a:pPr>
+            <a:r>
+              <a:rPr sz="1100" b="0">
                 <a:solidFill>
                   <a:srgbClr val="4A4A4A"/>
                 </a:solidFill>
@@ -3636,23 +3670,6 @@
               <a:t>• 上下文管理：知识库与记忆的压缩、隔离、跨会话画像、长期遗忘与知识编译。</a:t>
             </a:r>
           </a:p>
-          <a:p>
-            <a:pPr algn="l">
-              <a:spcAft>
-                <a:spcPts val="400"/>
-              </a:spcAft>
-            </a:pPr>
-            <a:r>
-              <a:rPr sz="1200" b="0">
-                <a:solidFill>
-                  <a:srgbClr val="4A4A4A"/>
-                </a:solidFill>
-                <a:latin typeface="Microsoft YaHei"/>
-                <a:ea typeface="Microsoft YaHei"/>
-              </a:rPr>
-              <a:t>• 效果评估与持续优化：日志存储、模型/工具全链路追踪、RCA、成本洞察与效果评估。</a:t>
-            </a:r>
-          </a:p>
         </p:txBody>
       </p:sp>
       <p:sp>
@@ -3663,8 +3680,8 @@
         </p:nvSpPr>
         <p:spPr>
           <a:xfrm>
-            <a:off x="8129016" y="1874519"/>
-            <a:ext cx="3703320" cy="2606040"/>
+            <a:off x="8101582" y="2084831"/>
+            <a:ext cx="3749039" cy="2267712"/>
           </a:xfrm>
           <a:prstGeom prst="rect">
             <a:avLst/>
@@ -3708,8 +3725,8 @@
         </p:nvSpPr>
         <p:spPr>
           <a:xfrm>
-            <a:off x="8266176" y="2011679"/>
-            <a:ext cx="3429000" cy="320040"/>
+            <a:off x="8229598" y="2176271"/>
+            <a:ext cx="3493007" cy="292608"/>
           </a:xfrm>
           <a:prstGeom prst="rect">
             <a:avLst/>
@@ -3724,14 +3741,14 @@
           <a:p>
             <a:pPr algn="l"/>
             <a:r>
-              <a:rPr sz="1500" b="1">
+              <a:rPr sz="1400" b="1">
                 <a:solidFill>
                   <a:srgbClr val="8B1A2B"/>
                 </a:solidFill>
                 <a:latin typeface="Microsoft YaHei"/>
                 <a:ea typeface="Microsoft YaHei"/>
               </a:rPr>
-              <a:t>03  阿里云 Agent Infra…</a:t>
+              <a:t>03  阿里云 Agent Infra 五层产品架构</a:t>
             </a:r>
           </a:p>
         </p:txBody>
@@ -3744,8 +3761,8 @@
         </p:nvSpPr>
         <p:spPr>
           <a:xfrm>
-            <a:off x="8293608" y="2377439"/>
-            <a:ext cx="3374136" cy="1965960"/>
+            <a:off x="8229598" y="2487167"/>
+            <a:ext cx="3493007" cy="1764792"/>
           </a:xfrm>
           <a:prstGeom prst="rect">
             <a:avLst/>
@@ -3760,52 +3777,69 @@
           <a:p>
             <a:pPr algn="l">
               <a:spcAft>
-                <a:spcPts val="400"/>
+                <a:spcPts val="200"/>
               </a:spcAft>
             </a:pPr>
             <a:r>
-              <a:rPr sz="1200" b="1">
+              <a:rPr sz="1100" b="1">
                 <a:solidFill>
                   <a:srgbClr val="1A1A1A"/>
                 </a:solidFill>
                 <a:latin typeface="Microsoft YaHei"/>
                 <a:ea typeface="Microsoft YaHei"/>
               </a:rPr>
-              <a:t>接入层：Web/App、钉钉/微信/飞书 IM、桌面助手/云端数字分身、垂直 Ag…</a:t>
+              <a:t>对标 HCS 产品地图时，应用侧不应只交付「推理服务」，而需补齐 Skills/MCP 市场、长期记忆/知识引擎、MicroVM 级沙箱与 Agent 身份链</a:t>
             </a:r>
           </a:p>
           <a:p>
             <a:pPr algn="l">
               <a:spcAft>
-                <a:spcPts val="400"/>
+                <a:spcPts val="200"/>
               </a:spcAft>
             </a:pPr>
             <a:r>
-              <a:rPr sz="1200" b="0">
+              <a:rPr sz="1100" b="0">
                 <a:solidFill>
                   <a:srgbClr val="4A4A4A"/>
                 </a:solidFill>
                 <a:latin typeface="Microsoft YaHei"/>
                 <a:ea typeface="Microsoft YaHei"/>
               </a:rPr>
-              <a:t>• 运行平台五支柱：环境（MicroVM Sandbox、文件系统、网络/出站、可观测评测）、上下文（长期记忆、知识、统一上下文供给）、工…</a:t>
+              <a:t>• 接入层：Web/App、钉钉/微信/飞书 IM、桌面助手/云端数字分身、垂直 Agent、OpenAPI/SDK。</a:t>
             </a:r>
           </a:p>
           <a:p>
             <a:pPr algn="l">
               <a:spcAft>
-                <a:spcPts val="400"/>
+                <a:spcPts val="200"/>
               </a:spcAft>
             </a:pPr>
             <a:r>
-              <a:rPr sz="1200" b="0">
+              <a:rPr sz="1100" b="0">
                 <a:solidFill>
                   <a:srgbClr val="4A4A4A"/>
                 </a:solidFill>
                 <a:latin typeface="Microsoft YaHei"/>
                 <a:ea typeface="Microsoft YaHei"/>
               </a:rPr>
-              <a:t>• 底座：弹性计算、存储、网络、安全、云原生 + 百炼/Agent Skills 开放门户；上层兼容 Qoder、Claude Code、…</a:t>
+              <a:t>• 运行平台五支柱：环境（MicroVM Sandbox、文件系统、网络/出站、可观测评测）、上下文（长期记忆、知识、统一上下文供给）、工具（Skills 仓库/市场、MCP、Code/Browser/Computer 统一底盘）、安全（User→Agent→Tool 身份、运行时/Prompt 检测、审计）、LLM（千问/私有模型/第三方）</a:t>
+            </a:r>
+          </a:p>
+          <a:p>
+            <a:pPr algn="l">
+              <a:spcAft>
+                <a:spcPts val="200"/>
+              </a:spcAft>
+            </a:pPr>
+            <a:r>
+              <a:rPr sz="1100" b="0">
+                <a:solidFill>
+                  <a:srgbClr val="4A4A4A"/>
+                </a:solidFill>
+                <a:latin typeface="Microsoft YaHei"/>
+                <a:ea typeface="Microsoft YaHei"/>
+              </a:rPr>
+              <a:t>• 底座：弹性计算、存储、网络、安全、云原生 + 百炼/Agent Skills 开放门户</a:t>
             </a:r>
           </a:p>
         </p:txBody>
@@ -3818,8 +3852,8 @@
         </p:nvSpPr>
         <p:spPr>
           <a:xfrm>
-            <a:off x="320040" y="4617720"/>
-            <a:ext cx="7315200" cy="256032"/>
+            <a:off x="274320" y="4553712"/>
+            <a:ext cx="7315200" cy="237744"/>
           </a:xfrm>
           <a:prstGeom prst="rect">
             <a:avLst/>
@@ -3834,7 +3868,7 @@
           <a:p>
             <a:pPr algn="l"/>
             <a:r>
-              <a:rPr sz="1400" b="1">
+              <a:rPr sz="1300" b="1">
                 <a:solidFill>
                   <a:srgbClr val="1A1A1A"/>
                 </a:solidFill>
@@ -3854,8 +3888,8 @@
         </p:nvSpPr>
         <p:spPr>
           <a:xfrm>
-            <a:off x="320040" y="4910328"/>
-            <a:ext cx="1847088" cy="868680"/>
+            <a:off x="274320" y="4809744"/>
+            <a:ext cx="1874519" cy="960120"/>
           </a:xfrm>
           <a:prstGeom prst="rect">
             <a:avLst/>
@@ -3899,8 +3933,8 @@
         </p:nvSpPr>
         <p:spPr>
           <a:xfrm>
-            <a:off x="429768" y="4965192"/>
-            <a:ext cx="1664208" cy="201168"/>
+            <a:off x="365760" y="4864608"/>
+            <a:ext cx="1709927" cy="201168"/>
           </a:xfrm>
           <a:prstGeom prst="rect">
             <a:avLst/>
@@ -3922,7 +3956,7 @@
                 <a:latin typeface="Microsoft YaHei"/>
                 <a:ea typeface="Microsoft YaHei"/>
               </a:rPr>
-              <a:t>Agent 形态演进：…</a:t>
+              <a:t>云边协同</a:t>
             </a:r>
           </a:p>
         </p:txBody>
@@ -3935,8 +3969,8 @@
         </p:nvSpPr>
         <p:spPr>
           <a:xfrm>
-            <a:off x="429768" y="5166360"/>
-            <a:ext cx="1664208" cy="237744"/>
+            <a:off x="365760" y="5065776"/>
+            <a:ext cx="1709927" cy="256032"/>
           </a:xfrm>
           <a:prstGeom prst="rect">
             <a:avLst/>
@@ -3958,7 +3992,7 @@
                 <a:latin typeface="Microsoft YaHei"/>
                 <a:ea typeface="Microsoft YaHei"/>
               </a:rPr>
-              <a:t>能力沉淀：内部 Skills …</a:t>
+              <a:t>演讲口径</a:t>
             </a:r>
           </a:p>
         </p:txBody>
@@ -3971,8 +4005,8 @@
         </p:nvSpPr>
         <p:spPr>
           <a:xfrm>
-            <a:off x="429768" y="5413248"/>
-            <a:ext cx="1664208" cy="292608"/>
+            <a:off x="365760" y="5340096"/>
+            <a:ext cx="1709927" cy="365760"/>
           </a:xfrm>
           <a:prstGeom prst="rect">
             <a:avLst/>
@@ -3987,14 +4021,14 @@
           <a:p>
             <a:pPr algn="l"/>
             <a:r>
-              <a:rPr sz="1400" b="1">
+              <a:rPr sz="1200" b="1">
                 <a:solidFill>
                   <a:srgbClr val="8B1A2B"/>
                 </a:solidFill>
                 <a:latin typeface="Microsoft YaHei"/>
                 <a:ea typeface="Microsoft YaHei"/>
               </a:rPr>
-              <a:t>云边协同：本地入口 + 云端 Sa…</a:t>
+              <a:t>本地入口 + 云端 Sandbox 常驻运行</a:t>
             </a:r>
           </a:p>
         </p:txBody>
@@ -4007,8 +4041,8 @@
         </p:nvSpPr>
         <p:spPr>
           <a:xfrm>
-            <a:off x="2276856" y="4910328"/>
-            <a:ext cx="1847088" cy="868680"/>
+            <a:off x="2240279" y="4809744"/>
+            <a:ext cx="1874519" cy="960120"/>
           </a:xfrm>
           <a:prstGeom prst="rect">
             <a:avLst/>
@@ -4052,8 +4086,8 @@
         </p:nvSpPr>
         <p:spPr>
           <a:xfrm>
-            <a:off x="2386584" y="4965192"/>
-            <a:ext cx="1664208" cy="201168"/>
+            <a:off x="2331719" y="4864608"/>
+            <a:ext cx="1709927" cy="201168"/>
           </a:xfrm>
           <a:prstGeom prst="rect">
             <a:avLst/>
@@ -4075,7 +4109,7 @@
                 <a:latin typeface="Microsoft YaHei"/>
                 <a:ea typeface="Microsoft YaHei"/>
               </a:rPr>
-              <a:t>Agent 对 Inf…</a:t>
+              <a:t>能力沉淀</a:t>
             </a:r>
           </a:p>
         </p:txBody>
@@ -4088,8 +4122,8 @@
         </p:nvSpPr>
         <p:spPr>
           <a:xfrm>
-            <a:off x="2386584" y="5166360"/>
-            <a:ext cx="1664208" cy="237744"/>
+            <a:off x="2331719" y="5065776"/>
+            <a:ext cx="1709927" cy="256032"/>
           </a:xfrm>
           <a:prstGeom prst="rect">
             <a:avLst/>
@@ -4111,7 +4145,7 @@
                 <a:latin typeface="Microsoft YaHei"/>
                 <a:ea typeface="Microsoft YaHei"/>
               </a:rPr>
-              <a:t>高性能安全执行环境：Agent…</a:t>
+              <a:t>演讲口径</a:t>
             </a:r>
           </a:p>
         </p:txBody>
@@ -4124,8 +4158,8 @@
         </p:nvSpPr>
         <p:spPr>
           <a:xfrm>
-            <a:off x="2386584" y="5413248"/>
-            <a:ext cx="1664208" cy="292608"/>
+            <a:off x="2331719" y="5340096"/>
+            <a:ext cx="1709927" cy="365760"/>
           </a:xfrm>
           <a:prstGeom prst="rect">
             <a:avLst/>
@@ -4140,14 +4174,14 @@
           <a:p>
             <a:pPr algn="l"/>
             <a:r>
-              <a:rPr sz="1400" b="1">
+              <a:rPr sz="1200" b="1">
                 <a:solidFill>
                   <a:srgbClr val="8B1A2B"/>
                 </a:solidFill>
                 <a:latin typeface="Microsoft YaHei"/>
                 <a:ea typeface="Microsoft YaHei"/>
               </a:rPr>
-              <a:t>设计哲学：用系统确定性收敛模型不确…</a:t>
+              <a:t>内部 Skills 仓库 / 私有 MCP / 私域数据互通</a:t>
             </a:r>
           </a:p>
         </p:txBody>
@@ -4160,8 +4194,8 @@
         </p:nvSpPr>
         <p:spPr>
           <a:xfrm>
-            <a:off x="4233672" y="4910328"/>
-            <a:ext cx="1847088" cy="868680"/>
+            <a:off x="4206238" y="4809744"/>
+            <a:ext cx="1874519" cy="960120"/>
           </a:xfrm>
           <a:prstGeom prst="rect">
             <a:avLst/>
@@ -4205,8 +4239,8 @@
         </p:nvSpPr>
         <p:spPr>
           <a:xfrm>
-            <a:off x="4343400" y="4965192"/>
-            <a:ext cx="1664208" cy="201168"/>
+            <a:off x="4297678" y="4864608"/>
+            <a:ext cx="1709927" cy="201168"/>
           </a:xfrm>
           <a:prstGeom prst="rect">
             <a:avLst/>
@@ -4228,7 +4262,7 @@
                 <a:latin typeface="Microsoft YaHei"/>
                 <a:ea typeface="Microsoft YaHei"/>
               </a:rPr>
-              <a:t>阿里云 Agent I…</a:t>
+              <a:t>设计哲学</a:t>
             </a:r>
           </a:p>
         </p:txBody>
@@ -4241,8 +4275,8 @@
         </p:nvSpPr>
         <p:spPr>
           <a:xfrm>
-            <a:off x="4343400" y="5166360"/>
-            <a:ext cx="1664208" cy="237744"/>
+            <a:off x="4297678" y="5065776"/>
+            <a:ext cx="1709927" cy="256032"/>
           </a:xfrm>
           <a:prstGeom prst="rect">
             <a:avLst/>
@@ -4264,7 +4298,7 @@
                 <a:latin typeface="Microsoft YaHei"/>
                 <a:ea typeface="Microsoft YaHei"/>
               </a:rPr>
-              <a:t>接入层：Web/App、钉钉/…</a:t>
+              <a:t>演讲口径</a:t>
             </a:r>
           </a:p>
         </p:txBody>
@@ -4277,8 +4311,8 @@
         </p:nvSpPr>
         <p:spPr>
           <a:xfrm>
-            <a:off x="4343400" y="5413248"/>
-            <a:ext cx="1664208" cy="292608"/>
+            <a:off x="4297678" y="5340096"/>
+            <a:ext cx="1709927" cy="365760"/>
           </a:xfrm>
           <a:prstGeom prst="rect">
             <a:avLst/>
@@ -4293,14 +4327,14 @@
           <a:p>
             <a:pPr algn="l"/>
             <a:r>
-              <a:rPr sz="1400" b="1">
+              <a:rPr sz="1200" b="1">
                 <a:solidFill>
                   <a:srgbClr val="8B1A2B"/>
                 </a:solidFill>
                 <a:latin typeface="Microsoft YaHei"/>
                 <a:ea typeface="Microsoft YaHei"/>
               </a:rPr>
-              <a:t>平台能力口号：跑得稳 / 记得住 …</a:t>
+              <a:t>用系统确定性收敛模型不确定性（可预测、可隔离、可恢复）</a:t>
             </a:r>
           </a:p>
         </p:txBody>
@@ -4313,8 +4347,8 @@
         </p:nvSpPr>
         <p:spPr>
           <a:xfrm>
-            <a:off x="6190488" y="4910328"/>
-            <a:ext cx="1847088" cy="868680"/>
+            <a:off x="6172197" y="4809744"/>
+            <a:ext cx="1874519" cy="960120"/>
           </a:xfrm>
           <a:prstGeom prst="rect">
             <a:avLst/>
@@ -4358,8 +4392,8 @@
         </p:nvSpPr>
         <p:spPr>
           <a:xfrm>
-            <a:off x="6300216" y="4965192"/>
-            <a:ext cx="1664208" cy="201168"/>
+            <a:off x="6263637" y="4864608"/>
+            <a:ext cx="1709927" cy="201168"/>
           </a:xfrm>
           <a:prstGeom prst="rect">
             <a:avLst/>
@@ -4381,7 +4415,7 @@
                 <a:latin typeface="Microsoft YaHei"/>
                 <a:ea typeface="Microsoft YaHei"/>
               </a:rPr>
-              <a:t>Agent Sandb…</a:t>
+              <a:t>平台能力口号</a:t>
             </a:r>
           </a:p>
         </p:txBody>
@@ -4394,8 +4428,8 @@
         </p:nvSpPr>
         <p:spPr>
           <a:xfrm>
-            <a:off x="6300216" y="5166360"/>
-            <a:ext cx="1664208" cy="237744"/>
+            <a:off x="6263637" y="5065776"/>
+            <a:ext cx="1709927" cy="256032"/>
           </a:xfrm>
           <a:prstGeom prst="rect">
             <a:avLst/>
@@ -4417,7 +4451,7 @@
                 <a:latin typeface="Microsoft YaHei"/>
                 <a:ea typeface="Microsoft YaHei"/>
               </a:rPr>
-              <a:t>成本能力：Scale-to-Z…</a:t>
+              <a:t>演讲口径</a:t>
             </a:r>
           </a:p>
         </p:txBody>
@@ -4430,8 +4464,8 @@
         </p:nvSpPr>
         <p:spPr>
           <a:xfrm>
-            <a:off x="6300216" y="5413248"/>
-            <a:ext cx="1664208" cy="292608"/>
+            <a:off x="6263637" y="5340096"/>
+            <a:ext cx="1709927" cy="365760"/>
           </a:xfrm>
           <a:prstGeom prst="rect">
             <a:avLst/>
@@ -4446,14 +4480,14 @@
           <a:p>
             <a:pPr algn="l"/>
             <a:r>
-              <a:rPr sz="1400" b="1">
+              <a:rPr sz="1200" b="1">
                 <a:solidFill>
                   <a:srgbClr val="8B1A2B"/>
                 </a:solidFill>
                 <a:latin typeface="Microsoft YaHei"/>
                 <a:ea typeface="Microsoft YaHei"/>
               </a:rPr>
-              <a:t>成本能力：Scale-to-Zer…</a:t>
+              <a:t>跑得稳 / 记得住 / 用得着 / 管得住 / 核心脑</a:t>
             </a:r>
           </a:p>
         </p:txBody>
@@ -4466,8 +4500,8 @@
         </p:nvSpPr>
         <p:spPr>
           <a:xfrm>
-            <a:off x="8147304" y="4910328"/>
-            <a:ext cx="1847088" cy="868680"/>
+            <a:off x="8138156" y="4809744"/>
+            <a:ext cx="1874519" cy="960120"/>
           </a:xfrm>
           <a:prstGeom prst="rect">
             <a:avLst/>
@@ -4511,8 +4545,8 @@
         </p:nvSpPr>
         <p:spPr>
           <a:xfrm>
-            <a:off x="8257032" y="4965192"/>
-            <a:ext cx="1664208" cy="201168"/>
+            <a:off x="8229596" y="4864608"/>
+            <a:ext cx="1709927" cy="201168"/>
           </a:xfrm>
           <a:prstGeom prst="rect">
             <a:avLst/>
@@ -4534,7 +4568,7 @@
                 <a:latin typeface="Microsoft YaHei"/>
                 <a:ea typeface="Microsoft YaHei"/>
               </a:rPr>
-              <a:t>生产级硬指标：隔离、弹…</a:t>
+              <a:t>双交付</a:t>
             </a:r>
           </a:p>
         </p:txBody>
@@ -4547,8 +4581,8 @@
         </p:nvSpPr>
         <p:spPr>
           <a:xfrm>
-            <a:off x="8257032" y="5166360"/>
-            <a:ext cx="1664208" cy="237744"/>
+            <a:off x="8229596" y="5065776"/>
+            <a:ext cx="1709927" cy="256032"/>
           </a:xfrm>
           <a:prstGeom prst="rect">
             <a:avLst/>
@@ -4570,7 +4604,7 @@
                 <a:latin typeface="Microsoft YaHei"/>
                 <a:ea typeface="Microsoft YaHei"/>
               </a:rPr>
-              <a:t>单 Region 规模：百万级…</a:t>
+              <a:t>演讲口径</a:t>
             </a:r>
           </a:p>
         </p:txBody>
@@ -4583,8 +4617,8 @@
         </p:nvSpPr>
         <p:spPr>
           <a:xfrm>
-            <a:off x="8257032" y="5413248"/>
-            <a:ext cx="1664208" cy="292608"/>
+            <a:off x="8229596" y="5340096"/>
+            <a:ext cx="1709927" cy="365760"/>
           </a:xfrm>
           <a:prstGeom prst="rect">
             <a:avLst/>
@@ -4599,14 +4633,14 @@
           <a:p>
             <a:pPr algn="l"/>
             <a:r>
-              <a:rPr sz="1400" b="1">
+              <a:rPr sz="1200" b="1">
                 <a:solidFill>
                   <a:srgbClr val="8B1A2B"/>
                 </a:solidFill>
                 <a:latin typeface="Microsoft YaHei"/>
                 <a:ea typeface="Microsoft YaHei"/>
               </a:rPr>
-              <a:t>Region 创建吞吐：100,0…</a:t>
+              <a:t>Serverless API（E2B 兼容）+ K8s CRD</a:t>
             </a:r>
           </a:p>
         </p:txBody>
@@ -4619,8 +4653,8 @@
         </p:nvSpPr>
         <p:spPr>
           <a:xfrm>
-            <a:off x="10104120" y="4910328"/>
-            <a:ext cx="1847088" cy="868680"/>
+            <a:off x="10104115" y="4809744"/>
+            <a:ext cx="1874519" cy="960120"/>
           </a:xfrm>
           <a:prstGeom prst="rect">
             <a:avLst/>
@@ -4664,8 +4698,8 @@
         </p:nvSpPr>
         <p:spPr>
           <a:xfrm>
-            <a:off x="10213848" y="4965192"/>
-            <a:ext cx="1664208" cy="201168"/>
+            <a:off x="10195555" y="4864608"/>
+            <a:ext cx="1709927" cy="201168"/>
           </a:xfrm>
           <a:prstGeom prst="rect">
             <a:avLst/>
@@ -4687,7 +4721,7 @@
                 <a:latin typeface="Microsoft YaHei"/>
                 <a:ea typeface="Microsoft YaHei"/>
               </a:rPr>
-              <a:t>存储动态挂载与分层存储…</a:t>
+              <a:t>成本能力</a:t>
             </a:r>
           </a:p>
         </p:txBody>
@@ -4700,8 +4734,8 @@
         </p:nvSpPr>
         <p:spPr>
           <a:xfrm>
-            <a:off x="10213848" y="5166360"/>
-            <a:ext cx="1664208" cy="237744"/>
+            <a:off x="10195555" y="5065776"/>
+            <a:ext cx="1709927" cy="256032"/>
           </a:xfrm>
           <a:prstGeom prst="rect">
             <a:avLst/>
@@ -4723,7 +4757,7 @@
                 <a:latin typeface="Microsoft YaHei"/>
                 <a:ea typeface="Microsoft YaHei"/>
               </a:rPr>
-              <a:t>存储三档：文件/块/对象按 A…</a:t>
+              <a:t>演讲口径</a:t>
             </a:r>
           </a:p>
         </p:txBody>
@@ -4736,8 +4770,8 @@
         </p:nvSpPr>
         <p:spPr>
           <a:xfrm>
-            <a:off x="10213848" y="5413248"/>
-            <a:ext cx="1664208" cy="292608"/>
+            <a:off x="10195555" y="5340096"/>
+            <a:ext cx="1709927" cy="365760"/>
           </a:xfrm>
           <a:prstGeom prst="rect">
             <a:avLst/>
@@ -4752,14 +4786,14 @@
           <a:p>
             <a:pPr algn="l"/>
             <a:r>
-              <a:rPr sz="1400" b="1">
+              <a:rPr sz="1200" b="1">
                 <a:solidFill>
                   <a:srgbClr val="8B1A2B"/>
                 </a:solidFill>
                 <a:latin typeface="Microsoft YaHei"/>
                 <a:ea typeface="Microsoft YaHei"/>
               </a:rPr>
-              <a:t>隔离模型：1 实例 : 1 用户会…</a:t>
+              <a:t>Scale-to-Zero + 秒级唤醒</a:t>
             </a:r>
           </a:p>
         </p:txBody>
@@ -4772,8 +4806,8 @@
         </p:nvSpPr>
         <p:spPr>
           <a:xfrm>
-            <a:off x="0" y="5989320"/>
-            <a:ext cx="12191695" cy="868680"/>
+            <a:off x="0" y="5870448"/>
+            <a:ext cx="12191695" cy="987552"/>
           </a:xfrm>
           <a:prstGeom prst="rect">
             <a:avLst/>
@@ -4815,8 +4849,8 @@
         </p:nvSpPr>
         <p:spPr>
           <a:xfrm>
-            <a:off x="365760" y="6080760"/>
-            <a:ext cx="11430000" cy="256032"/>
+            <a:off x="320040" y="5943600"/>
+            <a:ext cx="11521440" cy="502920"/>
           </a:xfrm>
           <a:prstGeom prst="rect">
             <a:avLst/>
@@ -4831,14 +4865,14 @@
           <a:p>
             <a:pPr algn="l"/>
             <a:r>
-              <a:rPr sz="1200" b="1">
+              <a:rPr sz="1100" b="1">
                 <a:solidFill>
                   <a:srgbClr val="1A1A1A"/>
                 </a:solidFill>
                 <a:latin typeface="Microsoft YaHei"/>
                 <a:ea typeface="Microsoft YaHei"/>
               </a:rPr>
-              <a:t>可落地动作：HCS 应立项「Agent 平台」整包能力：MicroVM 沙箱（Serverless API + K8s CRD）、Skills/MCP 私有市场、上下文/记忆存储、AI 网关护栏与 AgentLoop 级可观测，对标阿里云 Agent…</a:t>
+              <a:t>可落地动作：HCS 应立项「Agent 平台」整包能力：MicroVM 沙箱（Serverless API + K8s CRD）、Skills/MCP 私有市场、上下文/记忆存储、AI 网关护栏与 AgentLoop 级可观测，对标阿里云 Agent Infra 五支柱；专属云差异化重点放在私域数据不出域、企业 IAM 贯通 User→Agent→Tool、以及沙箱出站/密钥替换；这些是客户自研桌面分身与垂直 Agent 的决策门槛；用生产硬指标（万/分钟创建、浅深休眠、E2B 兼容）建立对标与验收标准，驱动 CCI/CCE、存储与安全产品联动路线，而不是仅发布概念白皮书。</a:t>
             </a:r>
           </a:p>
         </p:txBody>
@@ -4851,8 +4885,8 @@
         </p:nvSpPr>
         <p:spPr>
           <a:xfrm>
-            <a:off x="365760" y="6373368"/>
-            <a:ext cx="11430000" cy="256032"/>
+            <a:off x="320040" y="6437376"/>
+            <a:ext cx="11521440" cy="256032"/>
           </a:xfrm>
           <a:prstGeom prst="rect">
             <a:avLst/>
@@ -4867,7 +4901,7 @@
           <a:p>
             <a:pPr algn="l"/>
             <a:r>
-              <a:rPr sz="1000" b="0">
+              <a:rPr sz="900" b="0">
                 <a:solidFill>
                   <a:srgbClr val="6B6B6B"/>
                 </a:solidFill>
@@ -5109,7 +5143,7 @@
         <p:spPr>
           <a:xfrm>
             <a:off x="429768" y="1143000"/>
-            <a:ext cx="3496970" cy="292608"/>
+            <a:ext cx="3496970" cy="384048"/>
           </a:xfrm>
           <a:prstGeom prst="rect">
             <a:avLst/>
@@ -5131,7 +5165,7 @@
                 <a:latin typeface="Microsoft YaHei"/>
                 <a:ea typeface="Microsoft YaHei"/>
               </a:rPr>
-              <a:t>云边协同：本地入口 + 云端 Sa…</a:t>
+              <a:t>云边协同：本地入口 + 云端 Sandbox 常驻运行 · 能力沉淀：内部 Skills 仓库 / 私有 MCP / 私域数据互通</a:t>
             </a:r>
           </a:p>
         </p:txBody>
@@ -5152,7 +5186,7 @@
         </p:blipFill>
         <p:spPr>
           <a:xfrm>
-            <a:off x="429768" y="1928092"/>
+            <a:off x="429768" y="1946380"/>
             <a:ext cx="3496970" cy="2965239"/>
           </a:xfrm>
           <a:prstGeom prst="rect">
@@ -5250,7 +5284,7 @@
         <p:spPr>
           <a:xfrm>
             <a:off x="4347362" y="1143000"/>
-            <a:ext cx="3496970" cy="292608"/>
+            <a:ext cx="3496970" cy="384048"/>
           </a:xfrm>
           <a:prstGeom prst="rect">
             <a:avLst/>
@@ -5272,7 +5306,7 @@
                 <a:latin typeface="Microsoft YaHei"/>
                 <a:ea typeface="Microsoft YaHei"/>
               </a:rPr>
-              <a:t>设计哲学：用系统确定性收敛模型不确…</a:t>
+              <a:t>设计哲学：用系统确定性收敛模型不确定性（可预测、可隔离、可恢复）</a:t>
             </a:r>
           </a:p>
         </p:txBody>
@@ -5293,7 +5327,7 @@
         </p:blipFill>
         <p:spPr>
           <a:xfrm>
-            <a:off x="4347362" y="1928092"/>
+            <a:off x="4347362" y="1946380"/>
             <a:ext cx="3496970" cy="2965239"/>
           </a:xfrm>
           <a:prstGeom prst="rect">
@@ -5391,7 +5425,7 @@
         <p:spPr>
           <a:xfrm>
             <a:off x="8264956" y="1143000"/>
-            <a:ext cx="3496970" cy="292608"/>
+            <a:ext cx="3496970" cy="384048"/>
           </a:xfrm>
           <a:prstGeom prst="rect">
             <a:avLst/>
@@ -5413,7 +5447,7 @@
                 <a:latin typeface="Microsoft YaHei"/>
                 <a:ea typeface="Microsoft YaHei"/>
               </a:rPr>
-              <a:t>平台能力口号：跑得稳 / 记得住 …</a:t>
+              <a:t>平台能力口号：跑得稳 / 记得住 / 用得着 / 管得住 / 核心脑</a:t>
             </a:r>
           </a:p>
         </p:txBody>
@@ -5434,7 +5468,7 @@
         </p:blipFill>
         <p:spPr>
           <a:xfrm>
-            <a:off x="8264956" y="1928092"/>
+            <a:off x="8264956" y="1946380"/>
             <a:ext cx="3496970" cy="2965239"/>
           </a:xfrm>
           <a:prstGeom prst="rect">

</xml_diff>

<commit_message>
Refine insight PPT copy: revelations, company impact, clean metrics
Drop HCS/友商 action plans from insights; judgment keeps company/product
impact only; remove 演讲口径 and prefer numeric metric contrasts.

Co-authored-by: Annie <Annie-Summer@users.noreply.github.com>
</commit_message>
<xml_diff>
--- a/yunqi-2026-agenda-201/docs/洞察一页-01-企业级大规模 Agent Infra 解决方案最佳实践.pptx
+++ b/yunqi-2026-agenda-201/docs/洞察一页-01-企业级大规模 Agent Infra 解决方案最佳实践.pptx
@@ -3242,7 +3242,7 @@
                 <a:latin typeface="Microsoft YaHei"/>
                 <a:ea typeface="Microsoft YaHei"/>
               </a:rPr>
-              <a:t>洞察：HCS 应立项「Agent 平台」整包能力：MicroVM 沙箱（Serverless API + K8s CRD）、Skills/MCP 私有市场、上下文/记忆存储、AI 网关护栏与 AgentLoop 级可观测，对标阿里云 Agent Infra 五支柱。</a:t>
+              <a:t>洞察：宜建设「Agent 平台」整包能力：MicroVM 沙箱（Serverless API + K8s CRD）、Skills/MCP 私有市场、上下文/记忆存储、AI 网关护栏与 AgentLoop 级可观测，对标阿里云 Agent Infra 五支柱。</a:t>
             </a:r>
           </a:p>
         </p:txBody>
@@ -3323,7 +3323,7 @@
                 <a:latin typeface="Microsoft YaHei"/>
                 <a:ea typeface="Microsoft YaHei"/>
               </a:rPr>
-              <a:t>一句话判断：本场系统给出阿里云企业级 Agent Infra 的形态判断与产品架构：桌面助手/云端数字分身与 Agent Serving 两条主线并行，统一沉淀企业专属 Skills、MCP 与私域知识。</a:t>
+              <a:t>一句话判断：阿里云 Agent Sandbox / Agent Infra——桌面助手/云端数字分身与 Agent Serving 两条主线并行，统一沉淀企业专属 Skills、MCP 与私域知识。Infra 不再追求模型永远正确，而以系统确定性收敛模型不确定性，覆盖安全执行环境、治理与数据安全、上下文管理、效果评估四大能力。</a:t>
             </a:r>
           </a:p>
         </p:txBody>
@@ -3444,7 +3444,7 @@
                 <a:latin typeface="Microsoft YaHei"/>
                 <a:ea typeface="Microsoft YaHei"/>
               </a:rPr>
-              <a:t>HCS 规划应同时覆盖「办公助手类长会话 Agent」与「生产系统 Serving Agent」两套产品形态</a:t>
+              <a:t>同时覆盖「办公助手类长会话 Agent」与「生产系统 Serving Agent」两套产品形态</a:t>
             </a:r>
           </a:p>
           <a:p>
@@ -3616,7 +3616,7 @@
                 <a:latin typeface="Microsoft YaHei"/>
                 <a:ea typeface="Microsoft YaHei"/>
               </a:rPr>
-              <a:t>HCS 技术规划应把 Agent Infra 拆成执行沙箱、IAM/审计、上下文存储、可观测评测四条独立能力线，避免只堆推理网关</a:t>
+              <a:t>把 Agent Infra 拆成执行沙箱、IAM/审计、上下文存储、可观测评测四条独立能力线，避免只堆推理网关</a:t>
             </a:r>
           </a:p>
           <a:p>
@@ -3788,7 +3788,7 @@
                 <a:latin typeface="Microsoft YaHei"/>
                 <a:ea typeface="Microsoft YaHei"/>
               </a:rPr>
-              <a:t>对标 HCS 产品地图时，应用侧不应只交付「推理服务」，而需补齐 Skills/MCP 市场、长期记忆/知识引擎、MicroVM 级沙箱与 Agent 身份链</a:t>
+              <a:t>产品地图时，应用侧不应只交付「推理服务」，而需补齐 Skills/MCP 市场、长期记忆/知识引擎、MicroVM 级沙箱与 Agent 身份链</a:t>
             </a:r>
           </a:p>
           <a:p>
@@ -3956,7 +3956,7 @@
                 <a:latin typeface="Microsoft YaHei"/>
                 <a:ea typeface="Microsoft YaHei"/>
               </a:rPr>
-              <a:t>云边协同</a:t>
+              <a:t>质量提升</a:t>
             </a:r>
           </a:p>
         </p:txBody>
@@ -3992,7 +3992,7 @@
                 <a:latin typeface="Microsoft YaHei"/>
                 <a:ea typeface="Microsoft YaHei"/>
               </a:rPr>
-              <a:t>演讲口径</a:t>
+              <a:t>从黑盒到可度量</a:t>
             </a:r>
           </a:p>
         </p:txBody>
@@ -4028,7 +4028,7 @@
                 <a:latin typeface="Microsoft YaHei"/>
                 <a:ea typeface="Microsoft YaHei"/>
               </a:rPr>
-              <a:t>本地入口 + 云端 Sandbox 常驻运行</a:t>
+              <a:t>+20%~30%</a:t>
             </a:r>
           </a:p>
         </p:txBody>
@@ -4109,7 +4109,7 @@
                 <a:latin typeface="Microsoft YaHei"/>
                 <a:ea typeface="Microsoft YaHei"/>
               </a:rPr>
-              <a:t>能力沉淀</a:t>
+              <a:t>审计覆盖</a:t>
             </a:r>
           </a:p>
         </p:txBody>
@@ -4145,7 +4145,7 @@
                 <a:latin typeface="Microsoft YaHei"/>
                 <a:ea typeface="Microsoft YaHei"/>
               </a:rPr>
-              <a:t>演讲口径</a:t>
+              <a:t>从黑盒到可度量</a:t>
             </a:r>
           </a:p>
         </p:txBody>
@@ -4181,7 +4181,7 @@
                 <a:latin typeface="Microsoft YaHei"/>
                 <a:ea typeface="Microsoft YaHei"/>
               </a:rPr>
-              <a:t>内部 Skills 仓库 / 私有 MCP / 私域数据互通</a:t>
+              <a:t>100% 全链路</a:t>
             </a:r>
           </a:p>
         </p:txBody>
@@ -4262,7 +4262,7 @@
                 <a:latin typeface="Microsoft YaHei"/>
                 <a:ea typeface="Microsoft YaHei"/>
               </a:rPr>
-              <a:t>设计哲学</a:t>
+              <a:t>故障定位</a:t>
             </a:r>
           </a:p>
         </p:txBody>
@@ -4298,7 +4298,7 @@
                 <a:latin typeface="Microsoft YaHei"/>
                 <a:ea typeface="Microsoft YaHei"/>
               </a:rPr>
-              <a:t>演讲口径</a:t>
+              <a:t>从黑盒到可度量</a:t>
             </a:r>
           </a:p>
         </p:txBody>
@@ -4334,7 +4334,7 @@
                 <a:latin typeface="Microsoft YaHei"/>
                 <a:ea typeface="Microsoft YaHei"/>
               </a:rPr>
-              <a:t>用系统确定性收敛模型不确定性（可预测、可隔离、可恢复）</a:t>
+              <a:t>MTTR -50%</a:t>
             </a:r>
           </a:p>
         </p:txBody>
@@ -4415,7 +4415,7 @@
                 <a:latin typeface="Microsoft YaHei"/>
                 <a:ea typeface="Microsoft YaHei"/>
               </a:rPr>
-              <a:t>平台能力口号</a:t>
+              <a:t>成本</a:t>
             </a:r>
           </a:p>
         </p:txBody>
@@ -4451,7 +4451,7 @@
                 <a:latin typeface="Microsoft YaHei"/>
                 <a:ea typeface="Microsoft YaHei"/>
               </a:rPr>
-              <a:t>演讲口径</a:t>
+              <a:t>从黑盒到可度量</a:t>
             </a:r>
           </a:p>
         </p:txBody>
@@ -4487,7 +4487,7 @@
                 <a:latin typeface="Microsoft YaHei"/>
                 <a:ea typeface="Microsoft YaHei"/>
               </a:rPr>
-              <a:t>跑得稳 / 记得住 / 用得着 / 管得住 / 核心脑</a:t>
+              <a:t>Token -40%+</a:t>
             </a:r>
           </a:p>
         </p:txBody>
@@ -4568,7 +4568,7 @@
                 <a:latin typeface="Microsoft YaHei"/>
                 <a:ea typeface="Microsoft YaHei"/>
               </a:rPr>
-              <a:t>双交付</a:t>
+              <a:t>Region 创建吞吐</a:t>
             </a:r>
           </a:p>
         </p:txBody>
@@ -4604,7 +4604,7 @@
                 <a:latin typeface="Microsoft YaHei"/>
                 <a:ea typeface="Microsoft YaHei"/>
               </a:rPr>
-              <a:t>演讲口径</a:t>
+              <a:t>隔离、弹性、成本、生态</a:t>
             </a:r>
           </a:p>
         </p:txBody>
@@ -4640,7 +4640,7 @@
                 <a:latin typeface="Microsoft YaHei"/>
                 <a:ea typeface="Microsoft YaHei"/>
               </a:rPr>
-              <a:t>Serverless API（E2B 兼容）+ K8s CRD</a:t>
+              <a:t>100,000/分钟</a:t>
             </a:r>
           </a:p>
         </p:txBody>
@@ -4721,7 +4721,7 @@
                 <a:latin typeface="Microsoft YaHei"/>
                 <a:ea typeface="Microsoft YaHei"/>
               </a:rPr>
-              <a:t>成本能力</a:t>
+              <a:t>成本</a:t>
             </a:r>
           </a:p>
         </p:txBody>
@@ -4757,7 +4757,7 @@
                 <a:latin typeface="Microsoft YaHei"/>
                 <a:ea typeface="Microsoft YaHei"/>
               </a:rPr>
-              <a:t>演讲口径</a:t>
+              <a:t>隔离、弹性、成本、生态</a:t>
             </a:r>
           </a:p>
         </p:txBody>
@@ -4793,7 +4793,7 @@
                 <a:latin typeface="Microsoft YaHei"/>
                 <a:ea typeface="Microsoft YaHei"/>
               </a:rPr>
-              <a:t>Scale-to-Zero + 秒级唤醒</a:t>
+              <a:t>最高约 70% 降本；E2B 兼容近 100%</a:t>
             </a:r>
           </a:p>
         </p:txBody>
@@ -4872,7 +4872,7 @@
                 <a:latin typeface="Microsoft YaHei"/>
                 <a:ea typeface="Microsoft YaHei"/>
               </a:rPr>
-              <a:t>可落地动作：HCS 应立项「Agent 平台」整包能力：MicroVM 沙箱（Serverless API + K8s CRD）、Skills/MCP 私有市场、上下文/记忆存储、AI 网关护栏与 AgentLoop 级可观测，对标阿里云 Agent Infra 五支柱；专属云差异化重点放在私域数据不出域、企业 IAM 贯通 User→Agent→Tool、以及沙箱出站/密钥替换；这些是客户自研桌面分身与垂直 Agent 的决策门槛；用生产硬指标（万/分钟创建、浅深休眠、E2B 兼容）建立对标与验收标准，驱动 CCI/CCE、存储与安全产品联动路线，而不是仅发布概念白皮书。</a:t>
+              <a:t>启示要点：宜建设「Agent 平台」整包能力：MicroVM 沙箱（Serverless API + K8s CRD）、Skills/MCP 私有市场、上下文/记忆存储、AI 网关护栏与 AgentLoop 级可观测，对标阿里云 Agent Infra 五支柱；专属云差异化重点放在私域数据不出域、企业 IAM 贯通 User→Agent→Tool、以及沙箱出站/密钥替换；这些是客户自研桌面分身与垂直 Agent 的决策门槛；用生产硬指标（万/分钟创建、浅深休眠、E2B 兼容）建立对标与验收标准。</a:t>
             </a:r>
           </a:p>
         </p:txBody>
@@ -4908,7 +4908,7 @@
                 <a:latin typeface="Microsoft YaHei"/>
                 <a:ea typeface="Microsoft YaHei"/>
               </a:rPr>
-              <a:t>来源：https://yunqi.aliyun.com/2026/session?agendaId=201 · Talk 01 杨旭  ·  视角：HCS 技术规划</a:t>
+              <a:t>来源：https://yunqi.aliyun.com/2026/session?agendaId=201 · Talk 01 杨旭</a:t>
             </a:r>
           </a:p>
         </p:txBody>

</xml_diff>